<commit_message>
docs: refresh PMWorkspace audit artifacts
</commit_message>
<xml_diff>
--- a/artifacts/PMWorkspace运行逻辑与瘦身审计.pptx
+++ b/artifacts/PMWorkspace运行逻辑与瘦身审计.pptx
@@ -2983,7 +2983,7 @@
                 <a:ea typeface="Aptos Display"/>
                 <a:cs typeface="Aptos Display"/>
               </a:rPr>
-              <a:t>有生产截图时，402 x 874 不能进 prompt</a:t>
+              <a:t>有生产截图时，短画布锚点不能进 prompt</a:t>
             </a:r>
           </a:p>
         </p:txBody>
@@ -3047,7 +3047,7 @@
                 <a:ea typeface="Aptos"/>
                 <a:cs typeface="Aptos"/>
               </a:rPr>
-              <a:t>短画布锚点必须被 prompt check 和 image audit 双重拦截。</a:t>
+              <a:t>短画布锚点由脚本定义，并被 prompt check 和 image audit 双重拦截。</a:t>
             </a:r>
           </a:p>
         </p:txBody>
@@ -3427,7 +3427,7 @@
                 <a:ea typeface="Aptos"/>
                 <a:cs typeface="Aptos"/>
               </a:rPr>
-              <a:t>可用 iPhone 17 402 x 874</a:t>
+              <a:t>使用 standard_first_screen 模板</a:t>
             </a:r>
           </a:p>
           <a:p xmlns:a="http://schemas.openxmlformats.org/drawingml/2006/main">
@@ -3450,7 +3450,7 @@
                 <a:ea typeface="Aptos"/>
                 <a:cs typeface="Aptos"/>
               </a:rPr>
-              <a:t>适合新概念短首屏。</a:t>
+              <a:t>仅适合无视觉基线的新概念短首屏。</a:t>
             </a:r>
           </a:p>
         </p:txBody>
@@ -3888,7 +3888,7 @@
                 <a:ea typeface="Aptos"/>
                 <a:cs typeface="Aptos"/>
               </a:rPr>
-              <a:t>prompt 中不得出现 402 x 874 / W402 x H874 / H874 / 标准首屏 / 最低 H874。</a:t>
+              <a:t>prompt 中不得出现脚本定义的短画布锚点。</a:t>
             </a:r>
           </a:p>
         </p:txBody>
@@ -3952,7 +3952,7 @@
                 <a:ea typeface="Aptos Display"/>
                 <a:cs typeface="Aptos Display"/>
               </a:rPr>
-              <a:t>脚本责任：pmw-prototype-prompt-check 出图前挡旧 prompt；pmw-image-audit 出图后挡尺寸失败。</a:t>
+              <a:t>脚本责任：pmw-prototype-prompt-check 出图前挡短画布锚点；pmw-image-audit 出图后挡尺寸失败。</a:t>
             </a:r>
           </a:p>
         </p:txBody>
@@ -8369,7 +8369,7 @@
                 <a:ea typeface="Aptos"/>
                 <a:cs typeface="Aptos"/>
               </a:rPr>
-              <a:t>D1-D17 已处理，当前重点是防止旧锚点回流。</a:t>
+              <a:t>D1-D17 已处理，当前重点是防止旧规则回流。</a:t>
             </a:r>
           </a:p>
         </p:txBody>
@@ -9182,7 +9182,7 @@
                 <a:ea typeface="Aptos Display"/>
                 <a:cs typeface="Aptos Display"/>
               </a:rPr>
-              <a:t>补强：画布模板已拆成互斥模式，避免 402 x 874 和物理长板同场出现。</a:t>
+              <a:t>补强：画布模板已拆成互斥模式，入口文档只写模板 ID。</a:t>
             </a:r>
           </a:p>
         </p:txBody>
@@ -9365,7 +9365,7 @@
                 <a:ea typeface="Aptos Display"/>
                 <a:cs typeface="Aptos Display"/>
               </a:rPr>
-              <a:t>不要让旧锚点回来</a:t>
+              <a:t>不要让旧规则回来</a:t>
             </a:r>
           </a:p>
         </p:txBody>
@@ -9809,7 +9809,7 @@
                 <a:ea typeface="Aptos"/>
                 <a:cs typeface="Aptos"/>
               </a:rPr>
-              <a:t>prompt check 继续挡住短画布锚点</a:t>
+              <a:t>prompt check 继续挡住脚本定义的短画布锚点</a:t>
             </a:r>
           </a:p>
           <a:p xmlns:a="http://schemas.openxmlformats.org/drawingml/2006/main">

</xml_diff>